<commit_message>
Fix the model-availability guard, and report thresholds at their real precision
Two defects that a clean checkout exposes.

`requires_model` checked for `models/deployment.json`, which IS committed - it
is the record of which model was selected - rather than for the `.joblib` it
points at, which is a build product and is not. On a fresh clone the guard
therefore passed and nine tests tried to load a file that was never there. CI
caught it on the first run. The guard now reads deployment.json and confirms
the estimator it names is actually present; verified locally by hiding the
estimator, which turns 51 passed into 42 passed / 9 skipped.

Thresholds were rendered at 2 dp throughout. The sweep grid is 0.005, so the
frozen operating point 0.505 was being printed as "0.51" - a reader
reproducing at 0.51 would not get the reported numbers back. Every threshold
render in reports, decks, figures, notebooks and CLI output now carries 3 dp.
</commit_message>
<xml_diff>
--- a/deliverables/Arne_Ramos_AI_Capstone_Technical_Presentation.pptx
+++ b/deliverables/Arne_Ramos_AI_Capstone_Technical_Presentation.pptx
@@ -5522,7 +5522,7 @@
                   <a:srgbClr val="2A2A2A"/>
                 </a:solidFill>
               </a:rPr>
-              <a:t>0.51</a:t>
+              <a:t>0.505</a:t>
             </a:r>
             <a:r>
               <a:rPr sz="1500" b="0">
@@ -8836,7 +8836,7 @@
                   <a:srgbClr val="2A2A2A"/>
                 </a:solidFill>
               </a:rPr>
-              <a:t> — median score 0.35 against a 0.51 threshold, only 2% below 0.10, so the threshold is the dominant lever and borderline review genuinely helps</a:t>
+              <a:t> — median score 0.35 against a 0.505 threshold, only 2% below 0.10, so the threshold is the dominant lever and borderline review genuinely helps</a:t>
             </a:r>
           </a:p>
           <a:p>

</xml_diff>